<commit_message>
Integrate v0.2.0: real-font measurement, single-box bullets, examples
- Measure text with the fonts the deck renders in (brand fonts.<role>.file
  or fontconfig's match) so wrap and overflow warnings match the render
- Bullet lists are one text box with paragraphs; big titles grow upward
- Summary slides in the sample and catalog decks; summary warning only for
  sectioned decks; matrix accepts commentary
- README galleries for the new feature decks, version 0.2.0, CHANGELOG

Co-Authored-By: Claude Opus 5.5 <noreply@anthropic.com>
</commit_message>
<xml_diff>
--- a/docs/examples/ko-sample.pptx
+++ b/docs/examples/ko-sample.pptx
@@ -3879,8 +3879,8 @@
         </p:nvSpPr>
         <p:spPr>
           <a:xfrm>
-            <a:off x="812800" y="2112264"/>
-            <a:ext cx="8664448" cy="1536192"/>
+            <a:off x="812800" y="1190548"/>
+            <a:ext cx="8664448" cy="2457907"/>
           </a:xfrm>
           <a:prstGeom prst="rect">
             <a:avLst/>
@@ -3888,7 +3888,7 @@
           <a:noFill/>
         </p:spPr>
         <p:txBody>
-          <a:bodyPr wrap="square" lIns="0" tIns="0" rIns="0" bIns="0" anchor="t">
+          <a:bodyPr wrap="square" lIns="0" tIns="0" rIns="0" bIns="0" anchor="b">
             <a:noAutofit/>
           </a:bodyPr>
           <a:lstStyle/>
@@ -3921,7 +3921,7 @@
         <p:spPr>
           <a:xfrm>
             <a:off x="812800" y="3877055"/>
-            <a:ext cx="8664448" cy="292608"/>
+            <a:ext cx="7620000" cy="292608"/>
           </a:xfrm>
           <a:prstGeom prst="rect">
             <a:avLst/>
@@ -4089,7 +4089,7 @@
                 <a:ea typeface="Malgun Gothic"/>
                 <a:cs typeface="Arial"/>
               </a:rPr>
-              <a:t>검토 요청의 절반이 하루 이상 대기합니다</a:t>
+              <a:t>검토 요청의 절반이 하루 이상 대기</a:t>
             </a:r>
           </a:p>
         </p:txBody>
@@ -4753,7 +4753,7 @@
                 <a:ea typeface="Malgun Gothic"/>
                 <a:cs typeface="Arial"/>
               </a:rPr>
-              <a:t>반복 확인 항목은 자동화하고 판단은 사람이 합니다</a:t>
+              <a:t>반복 확인은 자동화하고 판단은 사람이 한다</a:t>
             </a:r>
           </a:p>
         </p:txBody>
@@ -5279,7 +5279,7 @@
                 <a:ea typeface="Malgun Gothic"/>
                 <a:cs typeface="Arial"/>
               </a:rPr>
-              <a:t>6주 안에 준비부터 판단까지 마칩니다</a:t>
+              <a:t>6주 안에 준비부터 확대 판단까지 완료</a:t>
             </a:r>
           </a:p>
         </p:txBody>
@@ -6121,8 +6121,8 @@
         </p:nvSpPr>
         <p:spPr>
           <a:xfrm>
-            <a:off x="812800" y="2880360"/>
-            <a:ext cx="9087104" cy="576072"/>
+            <a:off x="812800" y="2534716"/>
+            <a:ext cx="9087104" cy="921715"/>
           </a:xfrm>
           <a:prstGeom prst="rect">
             <a:avLst/>
@@ -6130,7 +6130,7 @@
           <a:noFill/>
         </p:spPr>
         <p:txBody>
-          <a:bodyPr wrap="square" lIns="0" tIns="0" rIns="0" bIns="0" anchor="t">
+          <a:bodyPr wrap="square" lIns="0" tIns="0" rIns="0" bIns="0" anchor="b">
             <a:noAutofit/>
           </a:bodyPr>
           <a:lstStyle/>
@@ -6185,7 +6185,7 @@
         <p:spPr>
           <a:xfrm>
             <a:off x="812800" y="3685031"/>
-            <a:ext cx="9087104" cy="292608"/>
+            <a:ext cx="7620000" cy="292608"/>
           </a:xfrm>
           <a:prstGeom prst="rect">
             <a:avLst/>
@@ -6251,8 +6251,8 @@
         </p:nvSpPr>
         <p:spPr>
           <a:xfrm>
-            <a:off x="812800" y="2441447"/>
-            <a:ext cx="10566400" cy="877823"/>
+            <a:off x="812800" y="1914753"/>
+            <a:ext cx="10566400" cy="1404518"/>
           </a:xfrm>
           <a:prstGeom prst="rect">
             <a:avLst/>
@@ -6260,7 +6260,7 @@
           <a:noFill/>
         </p:spPr>
         <p:txBody>
-          <a:bodyPr wrap="square" lIns="0" tIns="0" rIns="0" bIns="0" anchor="t">
+          <a:bodyPr wrap="square" lIns="0" tIns="0" rIns="0" bIns="0" anchor="b">
             <a:noAutofit/>
           </a:bodyPr>
           <a:lstStyle/>
@@ -6293,7 +6293,7 @@
         <p:spPr>
           <a:xfrm>
             <a:off x="812800" y="3547871"/>
-            <a:ext cx="10566400" cy="237744"/>
+            <a:ext cx="6191250" cy="237744"/>
           </a:xfrm>
           <a:prstGeom prst="rect">
             <a:avLst/>

</xml_diff>